<commit_message>
Update skills, template, and deliverables with latest refinements
Updated content-refresh and facilitator-guide skill definitions,
refined source registry mappings, and refreshed training template
and Developers training deck with latest content edits.
</commit_message>
<xml_diff>
--- a/Anthropic_Training_Template.pptx
+++ b/Anthropic_Training_Template.pptx
@@ -5,7 +5,7 @@
     <p:sldMasterId id="2147483655" r:id="rId1"/>
   </p:sldMasterIdLst>
   <p:notesMasterIdLst>
-    <p:notesMasterId r:id="rId22"/>
+    <p:notesMasterId r:id="rId27"/>
   </p:notesMasterIdLst>
   <p:sldIdLst>
     <p:sldId id="256" r:id="rId2"/>
@@ -28,11 +28,11 @@
     <p:sldId id="268" r:id="rId19"/>
     <p:sldId id="269" r:id="rId20"/>
     <p:sldId id="270" r:id="rId21"/>
-    <p:sldId id="277" r:id="rId27"/>
-    <p:sldId id="278" r:id="rId28"/>
-    <p:sldId id="279" r:id="rId29"/>
-    <p:sldId id="280" r:id="rId30"/>
-    <p:sldId id="281" r:id="rId31"/>
+    <p:sldId id="277" r:id="rId22"/>
+    <p:sldId id="278" r:id="rId23"/>
+    <p:sldId id="279" r:id="rId24"/>
+    <p:sldId id="280" r:id="rId25"/>
+    <p:sldId id="281" r:id="rId26"/>
   </p:sldIdLst>
   <p:sldSz cx="9144000" cy="5143500" type="screen16x9"/>
   <p:notesSz cx="5143500" cy="9144000"/>
@@ -2953,14 +2953,6 @@
         </p:txBody>
       </p:sp>
     </p:spTree>
-    <p:bg>
-      <p:bgPr>
-        <a:solidFill>
-          <a:srgbClr val="D97757"/>
-        </a:solidFill>
-        <a:effectLst/>
-      </p:bgPr>
-    </p:bg>
   </p:cSld>
   <p:clrMapOvr>
     <a:masterClrMapping/>
@@ -3699,7 +3691,7 @@
                 <a:ea typeface="Test Tiempos Text" pitchFamily="34" charset="-122"/>
                 <a:cs typeface="Test Tiempos Text" pitchFamily="34" charset="-120"/>
               </a:rPr>
-              <a:t xml:space="preserve">  —  [Source or additional context]</a:t>
+              <a:t>  —  [Source or additional context]</a:t>
             </a:r>
             <a:endParaRPr lang="en-US" sz="1100" dirty="0"/>
           </a:p>
@@ -11494,7 +11486,7 @@
                 <a:ea typeface="Test Tiempos Text" pitchFamily="34" charset="-122"/>
                 <a:cs typeface="Test Tiempos Text" pitchFamily="34" charset="-120"/>
               </a:rPr>
-              <a:t xml:space="preserve">  —  [additional context]</a:t>
+              <a:t>  —  [additional context]</a:t>
             </a:r>
             <a:endParaRPr lang="en-US" sz="1100" dirty="0"/>
           </a:p>
@@ -12756,7 +12748,7 @@
 <file path=ppt/theme/theme1.xml><?xml version="1.0" encoding="utf-8"?>
 <a:theme xmlns:a="http://schemas.openxmlformats.org/drawingml/2006/main" name="Anthropic theme">
   <a:themeElements>
-    <a:clrScheme name="Custom 1">
+    <a:clrScheme name="Custom 2">
       <a:dk1>
         <a:srgbClr val="141413"/>
       </a:dk1>

</xml_diff>